<commit_message>
fix: suppression de la troncature des bullets dans les fiches animateur
get_first_bullet() coupait à 90 chars en dur, get_bullets() à 75.
Les textbox ont word_wrap=True — le texte s'adapte naturellement.

Co-Authored-By: Claude Sonnet 4.6 <noreply@anthropic.com>
</commit_message>
<xml_diff>
--- a/assets/fiches/A1-fiche-1h.pptx
+++ b/assets/fiches/A1-fiche-1h.pptx
@@ -3968,7 +3968,7 @@
                 </a:solidFill>
                 <a:latin typeface="Arial"/>
               </a:rPr>
-              <a:t>. Un ordinateur est une machine qui vous permet d'écrire, de communiquer, de chercher des in…</a:t>
+              <a:t>. Un ordinateur est une machine qui vous permet d'écrire, de communiquer, de chercher des informations et bien plus encore. Il en existe plusieurs formes selon vos besoins.</a:t>
             </a:r>
           </a:p>
         </p:txBody>
@@ -4462,7 +4462,7 @@
                 </a:solidFill>
                 <a:latin typeface="Arial"/>
               </a:rPr>
-              <a:t>. Ces gestes simples protègent votre ordinateur et évitent les pertes de données. À pratique…</a:t>
+              <a:t>. Ces gestes simples protègent votre ordinateur et évitent les pertes de données. À pratiquer dès le premier jour !</a:t>
             </a:r>
           </a:p>
         </p:txBody>
@@ -4709,7 +4709,7 @@
                 </a:solidFill>
                 <a:latin typeface="Arial"/>
               </a:rPr>
-              <a:t>. Le bureau, c'est votre espace de travail principal. Trois zones essentielles à repérer dès…</a:t>
+              <a:t>. Le bureau, c'est votre espace de travail principal. Trois zones essentielles à repérer dès le départ.</a:t>
             </a:r>
           </a:p>
         </p:txBody>
@@ -4956,7 +4956,7 @@
                 </a:solidFill>
                 <a:latin typeface="Arial"/>
               </a:rPr>
-              <a:t>. La souris vous permet d'interagir avec tout ce qui est à l'écran. Prenez le temps de bien …</a:t>
+              <a:t>. La souris vous permet d'interagir avec tout ce qui est à l'écran. Prenez le temps de bien la tenir, et entraînez-vous à ces quatre gestes fondamentaux.</a:t>
             </a:r>
           </a:p>
         </p:txBody>
@@ -5203,7 +5203,7 @@
                 </a:solidFill>
                 <a:latin typeface="Arial"/>
               </a:rPr>
-              <a:t>. Pas besoin de connaître toutes les touches ! Voici les indispensables pour écrire et navig…</a:t>
+              <a:t>. Pas besoin de connaître toutes les touches ! Voici les indispensables pour écrire et naviguer confortablement.</a:t>
             </a:r>
           </a:p>
         </p:txBody>
@@ -5450,7 +5450,7 @@
                 </a:solidFill>
                 <a:latin typeface="Arial"/>
               </a:rPr>
-              <a:t>. Chaque programme s'ouvre dans une fenêtre. Trois petits boutons en haut à droite vous perm…</a:t>
+              <a:t>. Chaque programme s'ouvre dans une fenêtre. Trois petits boutons en haut à droite vous permettent de tout contrôler.</a:t>
             </a:r>
           </a:p>
         </p:txBody>

</xml_diff>

<commit_message>
feat: fond de page CD47 avec 20% transparence sur fiches et mémos
Injection de bg-p1.png (logo CD47) en page 1 et bg-p2.png (sans logo)
sur les pages suivantes. Transparence 80% (20% transparent) via
alphaModFix sur le blip XML. S'applique à generate_fiches.py et
generate_memos.py.

Co-Authored-By: Claude Sonnet 4.6 <noreply@anthropic.com>
</commit_message>
<xml_diff>
--- a/assets/fiches/A1-fiche-1h.pptx
+++ b/assets/fiches/A1-fiche-1h.pptx
@@ -3096,9 +3096,35 @@
         <p:nvPr/>
       </p:nvGrpSpPr>
       <p:grpSpPr/>
-      <p:sp>
-        <p:nvSpPr>
-          <p:cNvPr id="2" name="TextBox 1"/>
+      <p:pic>
+        <p:nvPicPr>
+          <p:cNvPr id="2" name="Picture 1" descr="bg-p1.png"/>
+          <p:cNvPicPr>
+            <a:picLocks noChangeAspect="1"/>
+          </p:cNvPicPr>
+          <p:nvPr/>
+        </p:nvPicPr>
+        <p:blipFill>
+          <a:blip r:embed="rId2">
+            <a:alphaModFix amt="80000"/>
+          </a:blip>
+          <a:stretch>
+            <a:fillRect/>
+          </a:stretch>
+        </p:blipFill>
+        <p:spPr>
+          <a:xfrm>
+            <a:off x="0" y="0"/>
+            <a:ext cx="7556399" cy="10692000"/>
+          </a:xfrm>
+          <a:prstGeom prst="rect">
+            <a:avLst/>
+          </a:prstGeom>
+        </p:spPr>
+      </p:pic>
+      <p:sp>
+        <p:nvSpPr>
+          <p:cNvPr id="3" name="TextBox 2"/>
           <p:cNvSpPr txBox="1"/>
           <p:nvPr/>
         </p:nvSpPr>
@@ -3159,7 +3185,7 @@
       </p:sp>
       <p:sp>
         <p:nvSpPr>
-          <p:cNvPr id="3" name="Rectangle 2"/>
+          <p:cNvPr id="4" name="Rectangle 3"/>
           <p:cNvSpPr/>
           <p:nvPr/>
         </p:nvSpPr>
@@ -3202,7 +3228,7 @@
       </p:sp>
       <p:sp>
         <p:nvSpPr>
-          <p:cNvPr id="4" name="TextBox 3"/>
+          <p:cNvPr id="5" name="TextBox 4"/>
           <p:cNvSpPr txBox="1"/>
           <p:nvPr/>
         </p:nvSpPr>
@@ -3320,7 +3346,7 @@
       </p:sp>
       <p:sp>
         <p:nvSpPr>
-          <p:cNvPr id="5" name="Rectangle 4"/>
+          <p:cNvPr id="6" name="Rectangle 5"/>
           <p:cNvSpPr/>
           <p:nvPr/>
         </p:nvSpPr>
@@ -3363,7 +3389,7 @@
       </p:sp>
       <p:sp>
         <p:nvSpPr>
-          <p:cNvPr id="6" name="TextBox 5"/>
+          <p:cNvPr id="7" name="TextBox 6"/>
           <p:cNvSpPr txBox="1"/>
           <p:nvPr/>
         </p:nvSpPr>
@@ -3481,7 +3507,7 @@
       </p:sp>
       <p:sp>
         <p:nvSpPr>
-          <p:cNvPr id="7" name="Rectangle 6"/>
+          <p:cNvPr id="8" name="Rectangle 7"/>
           <p:cNvSpPr/>
           <p:nvPr/>
         </p:nvSpPr>
@@ -3524,7 +3550,7 @@
       </p:sp>
       <p:sp>
         <p:nvSpPr>
-          <p:cNvPr id="8" name="Rectangle 7"/>
+          <p:cNvPr id="9" name="Rectangle 8"/>
           <p:cNvSpPr/>
           <p:nvPr/>
         </p:nvSpPr>
@@ -3565,7 +3591,7 @@
       </p:sp>
       <p:sp>
         <p:nvSpPr>
-          <p:cNvPr id="9" name="Rectangle 8"/>
+          <p:cNvPr id="10" name="Rectangle 9"/>
           <p:cNvSpPr/>
           <p:nvPr/>
         </p:nvSpPr>
@@ -3606,7 +3632,7 @@
       </p:sp>
       <p:sp>
         <p:nvSpPr>
-          <p:cNvPr id="10" name="TextBox 9"/>
+          <p:cNvPr id="11" name="TextBox 10"/>
           <p:cNvSpPr txBox="1"/>
           <p:nvPr/>
         </p:nvSpPr>
@@ -3648,7 +3674,7 @@
       </p:sp>
       <p:sp>
         <p:nvSpPr>
-          <p:cNvPr id="11" name="TextBox 10"/>
+          <p:cNvPr id="12" name="TextBox 11"/>
           <p:cNvSpPr txBox="1"/>
           <p:nvPr/>
         </p:nvSpPr>
@@ -3728,7 +3754,7 @@
       </p:sp>
       <p:sp>
         <p:nvSpPr>
-          <p:cNvPr id="12" name="Rectangle 11"/>
+          <p:cNvPr id="13" name="Rectangle 12"/>
           <p:cNvSpPr/>
           <p:nvPr/>
         </p:nvSpPr>
@@ -3771,7 +3797,7 @@
       </p:sp>
       <p:sp>
         <p:nvSpPr>
-          <p:cNvPr id="13" name="Rectangle 12"/>
+          <p:cNvPr id="14" name="Rectangle 13"/>
           <p:cNvSpPr/>
           <p:nvPr/>
         </p:nvSpPr>
@@ -3812,7 +3838,7 @@
       </p:sp>
       <p:sp>
         <p:nvSpPr>
-          <p:cNvPr id="14" name="Rectangle 13"/>
+          <p:cNvPr id="15" name="Rectangle 14"/>
           <p:cNvSpPr/>
           <p:nvPr/>
         </p:nvSpPr>
@@ -3853,7 +3879,7 @@
       </p:sp>
       <p:sp>
         <p:nvSpPr>
-          <p:cNvPr id="15" name="TextBox 14"/>
+          <p:cNvPr id="16" name="TextBox 15"/>
           <p:cNvSpPr txBox="1"/>
           <p:nvPr/>
         </p:nvSpPr>
@@ -3895,7 +3921,7 @@
       </p:sp>
       <p:sp>
         <p:nvSpPr>
-          <p:cNvPr id="16" name="TextBox 15"/>
+          <p:cNvPr id="17" name="TextBox 16"/>
           <p:cNvSpPr txBox="1"/>
           <p:nvPr/>
         </p:nvSpPr>
@@ -3975,7 +4001,7 @@
       </p:sp>
       <p:sp>
         <p:nvSpPr>
-          <p:cNvPr id="17" name="Rectangle 16"/>
+          <p:cNvPr id="18" name="Rectangle 17"/>
           <p:cNvSpPr/>
           <p:nvPr/>
         </p:nvSpPr>
@@ -4018,7 +4044,7 @@
       </p:sp>
       <p:sp>
         <p:nvSpPr>
-          <p:cNvPr id="18" name="Rectangle 17"/>
+          <p:cNvPr id="19" name="Rectangle 18"/>
           <p:cNvSpPr/>
           <p:nvPr/>
         </p:nvSpPr>
@@ -4059,7 +4085,7 @@
       </p:sp>
       <p:sp>
         <p:nvSpPr>
-          <p:cNvPr id="19" name="Rectangle 18"/>
+          <p:cNvPr id="20" name="Rectangle 19"/>
           <p:cNvSpPr/>
           <p:nvPr/>
         </p:nvSpPr>
@@ -4100,7 +4126,7 @@
       </p:sp>
       <p:sp>
         <p:nvSpPr>
-          <p:cNvPr id="20" name="TextBox 19"/>
+          <p:cNvPr id="21" name="TextBox 20"/>
           <p:cNvSpPr txBox="1"/>
           <p:nvPr/>
         </p:nvSpPr>
@@ -4142,7 +4168,7 @@
       </p:sp>
       <p:sp>
         <p:nvSpPr>
-          <p:cNvPr id="21" name="TextBox 20"/>
+          <p:cNvPr id="22" name="TextBox 21"/>
           <p:cNvSpPr txBox="1"/>
           <p:nvPr/>
         </p:nvSpPr>
@@ -4222,7 +4248,7 @@
       </p:sp>
       <p:sp>
         <p:nvSpPr>
-          <p:cNvPr id="22" name="Rectangle 21"/>
+          <p:cNvPr id="23" name="Rectangle 22"/>
           <p:cNvSpPr/>
           <p:nvPr/>
         </p:nvSpPr>
@@ -4265,7 +4291,7 @@
       </p:sp>
       <p:sp>
         <p:nvSpPr>
-          <p:cNvPr id="23" name="Rectangle 22"/>
+          <p:cNvPr id="24" name="Rectangle 23"/>
           <p:cNvSpPr/>
           <p:nvPr/>
         </p:nvSpPr>
@@ -4306,7 +4332,7 @@
       </p:sp>
       <p:sp>
         <p:nvSpPr>
-          <p:cNvPr id="24" name="Rectangle 23"/>
+          <p:cNvPr id="25" name="Rectangle 24"/>
           <p:cNvSpPr/>
           <p:nvPr/>
         </p:nvSpPr>
@@ -4347,7 +4373,7 @@
       </p:sp>
       <p:sp>
         <p:nvSpPr>
-          <p:cNvPr id="25" name="TextBox 24"/>
+          <p:cNvPr id="26" name="TextBox 25"/>
           <p:cNvSpPr txBox="1"/>
           <p:nvPr/>
         </p:nvSpPr>
@@ -4389,7 +4415,7 @@
       </p:sp>
       <p:sp>
         <p:nvSpPr>
-          <p:cNvPr id="26" name="TextBox 25"/>
+          <p:cNvPr id="27" name="TextBox 26"/>
           <p:cNvSpPr txBox="1"/>
           <p:nvPr/>
         </p:nvSpPr>
@@ -4469,7 +4495,7 @@
       </p:sp>
       <p:sp>
         <p:nvSpPr>
-          <p:cNvPr id="27" name="Rectangle 26"/>
+          <p:cNvPr id="28" name="Rectangle 27"/>
           <p:cNvSpPr/>
           <p:nvPr/>
         </p:nvSpPr>
@@ -4512,7 +4538,7 @@
       </p:sp>
       <p:sp>
         <p:nvSpPr>
-          <p:cNvPr id="28" name="Rectangle 27"/>
+          <p:cNvPr id="29" name="Rectangle 28"/>
           <p:cNvSpPr/>
           <p:nvPr/>
         </p:nvSpPr>
@@ -4553,7 +4579,7 @@
       </p:sp>
       <p:sp>
         <p:nvSpPr>
-          <p:cNvPr id="29" name="Rectangle 28"/>
+          <p:cNvPr id="30" name="Rectangle 29"/>
           <p:cNvSpPr/>
           <p:nvPr/>
         </p:nvSpPr>
@@ -4594,7 +4620,7 @@
       </p:sp>
       <p:sp>
         <p:nvSpPr>
-          <p:cNvPr id="30" name="TextBox 29"/>
+          <p:cNvPr id="31" name="TextBox 30"/>
           <p:cNvSpPr txBox="1"/>
           <p:nvPr/>
         </p:nvSpPr>
@@ -4636,7 +4662,7 @@
       </p:sp>
       <p:sp>
         <p:nvSpPr>
-          <p:cNvPr id="31" name="TextBox 30"/>
+          <p:cNvPr id="32" name="TextBox 31"/>
           <p:cNvSpPr txBox="1"/>
           <p:nvPr/>
         </p:nvSpPr>
@@ -4716,7 +4742,7 @@
       </p:sp>
       <p:sp>
         <p:nvSpPr>
-          <p:cNvPr id="32" name="Rectangle 31"/>
+          <p:cNvPr id="33" name="Rectangle 32"/>
           <p:cNvSpPr/>
           <p:nvPr/>
         </p:nvSpPr>
@@ -4759,7 +4785,7 @@
       </p:sp>
       <p:sp>
         <p:nvSpPr>
-          <p:cNvPr id="33" name="Rectangle 32"/>
+          <p:cNvPr id="34" name="Rectangle 33"/>
           <p:cNvSpPr/>
           <p:nvPr/>
         </p:nvSpPr>
@@ -4800,7 +4826,7 @@
       </p:sp>
       <p:sp>
         <p:nvSpPr>
-          <p:cNvPr id="34" name="Rectangle 33"/>
+          <p:cNvPr id="35" name="Rectangle 34"/>
           <p:cNvSpPr/>
           <p:nvPr/>
         </p:nvSpPr>
@@ -4841,7 +4867,7 @@
       </p:sp>
       <p:sp>
         <p:nvSpPr>
-          <p:cNvPr id="35" name="TextBox 34"/>
+          <p:cNvPr id="36" name="TextBox 35"/>
           <p:cNvSpPr txBox="1"/>
           <p:nvPr/>
         </p:nvSpPr>
@@ -4883,7 +4909,7 @@
       </p:sp>
       <p:sp>
         <p:nvSpPr>
-          <p:cNvPr id="36" name="TextBox 35"/>
+          <p:cNvPr id="37" name="TextBox 36"/>
           <p:cNvSpPr txBox="1"/>
           <p:nvPr/>
         </p:nvSpPr>
@@ -4963,7 +4989,7 @@
       </p:sp>
       <p:sp>
         <p:nvSpPr>
-          <p:cNvPr id="37" name="Rectangle 36"/>
+          <p:cNvPr id="38" name="Rectangle 37"/>
           <p:cNvSpPr/>
           <p:nvPr/>
         </p:nvSpPr>
@@ -5006,7 +5032,7 @@
       </p:sp>
       <p:sp>
         <p:nvSpPr>
-          <p:cNvPr id="38" name="Rectangle 37"/>
+          <p:cNvPr id="39" name="Rectangle 38"/>
           <p:cNvSpPr/>
           <p:nvPr/>
         </p:nvSpPr>
@@ -5047,7 +5073,7 @@
       </p:sp>
       <p:sp>
         <p:nvSpPr>
-          <p:cNvPr id="39" name="Rectangle 38"/>
+          <p:cNvPr id="40" name="Rectangle 39"/>
           <p:cNvSpPr/>
           <p:nvPr/>
         </p:nvSpPr>
@@ -5088,7 +5114,7 @@
       </p:sp>
       <p:sp>
         <p:nvSpPr>
-          <p:cNvPr id="40" name="TextBox 39"/>
+          <p:cNvPr id="41" name="TextBox 40"/>
           <p:cNvSpPr txBox="1"/>
           <p:nvPr/>
         </p:nvSpPr>
@@ -5130,7 +5156,7 @@
       </p:sp>
       <p:sp>
         <p:nvSpPr>
-          <p:cNvPr id="41" name="TextBox 40"/>
+          <p:cNvPr id="42" name="TextBox 41"/>
           <p:cNvSpPr txBox="1"/>
           <p:nvPr/>
         </p:nvSpPr>
@@ -5210,7 +5236,7 @@
       </p:sp>
       <p:sp>
         <p:nvSpPr>
-          <p:cNvPr id="42" name="Rectangle 41"/>
+          <p:cNvPr id="43" name="Rectangle 42"/>
           <p:cNvSpPr/>
           <p:nvPr/>
         </p:nvSpPr>
@@ -5253,7 +5279,7 @@
       </p:sp>
       <p:sp>
         <p:nvSpPr>
-          <p:cNvPr id="43" name="Rectangle 42"/>
+          <p:cNvPr id="44" name="Rectangle 43"/>
           <p:cNvSpPr/>
           <p:nvPr/>
         </p:nvSpPr>
@@ -5294,7 +5320,7 @@
       </p:sp>
       <p:sp>
         <p:nvSpPr>
-          <p:cNvPr id="44" name="Rectangle 43"/>
+          <p:cNvPr id="45" name="Rectangle 44"/>
           <p:cNvSpPr/>
           <p:nvPr/>
         </p:nvSpPr>
@@ -5335,7 +5361,7 @@
       </p:sp>
       <p:sp>
         <p:nvSpPr>
-          <p:cNvPr id="45" name="TextBox 44"/>
+          <p:cNvPr id="46" name="TextBox 45"/>
           <p:cNvSpPr txBox="1"/>
           <p:nvPr/>
         </p:nvSpPr>
@@ -5377,7 +5403,7 @@
       </p:sp>
       <p:sp>
         <p:nvSpPr>
-          <p:cNvPr id="46" name="TextBox 45"/>
+          <p:cNvPr id="47" name="TextBox 46"/>
           <p:cNvSpPr txBox="1"/>
           <p:nvPr/>
         </p:nvSpPr>
@@ -5457,7 +5483,7 @@
       </p:sp>
       <p:sp>
         <p:nvSpPr>
-          <p:cNvPr id="47" name="Rectangle 46"/>
+          <p:cNvPr id="48" name="Rectangle 47"/>
           <p:cNvSpPr/>
           <p:nvPr/>
         </p:nvSpPr>
@@ -5498,7 +5524,7 @@
       </p:sp>
       <p:sp>
         <p:nvSpPr>
-          <p:cNvPr id="48" name="TextBox 47"/>
+          <p:cNvPr id="49" name="TextBox 48"/>
           <p:cNvSpPr txBox="1"/>
           <p:nvPr/>
         </p:nvSpPr>

</xml_diff>

<commit_message>
feat: slide-plans.json + fiches animateur + mémos mis à jour automatiquement
</commit_message>
<xml_diff>
--- a/assets/fiches/A1-fiche-1h.pptx
+++ b/assets/fiches/A1-fiche-1h.pptx
@@ -3083,9 +3083,12 @@
   <p:cSld>
     <p:bg>
       <p:bgPr>
-        <a:solidFill>
-          <a:srgbClr val="FFFFFF"/>
-        </a:solidFill>
+        <a:blipFill>
+          <a:blip r:embed="rId2"/>
+          <a:stretch>
+            <a:fillRect/>
+          </a:stretch>
+        </a:blipFill>
         <a:effectLst/>
       </p:bgPr>
     </p:bg>
@@ -3096,35 +3099,9 @@
         <p:nvPr/>
       </p:nvGrpSpPr>
       <p:grpSpPr/>
-      <p:pic>
-        <p:nvPicPr>
-          <p:cNvPr id="2" name="Picture 1" descr="bg-p1.png"/>
-          <p:cNvPicPr>
-            <a:picLocks noChangeAspect="1"/>
-          </p:cNvPicPr>
-          <p:nvPr/>
-        </p:nvPicPr>
-        <p:blipFill>
-          <a:blip r:embed="rId2">
-            <a:alphaModFix amt="80000"/>
-          </a:blip>
-          <a:stretch>
-            <a:fillRect/>
-          </a:stretch>
-        </p:blipFill>
-        <p:spPr>
-          <a:xfrm>
-            <a:off x="0" y="0"/>
-            <a:ext cx="7556399" cy="10692000"/>
-          </a:xfrm>
-          <a:prstGeom prst="rect">
-            <a:avLst/>
-          </a:prstGeom>
-        </p:spPr>
-      </p:pic>
-      <p:sp>
-        <p:nvSpPr>
-          <p:cNvPr id="3" name="TextBox 2"/>
+      <p:sp>
+        <p:nvSpPr>
+          <p:cNvPr id="2" name="TextBox 1"/>
           <p:cNvSpPr txBox="1"/>
           <p:nvPr/>
         </p:nvSpPr>
@@ -3185,7 +3162,7 @@
       </p:sp>
       <p:sp>
         <p:nvSpPr>
-          <p:cNvPr id="4" name="Rectangle 3"/>
+          <p:cNvPr id="3" name="Rectangle 2"/>
           <p:cNvSpPr/>
           <p:nvPr/>
         </p:nvSpPr>
@@ -3228,7 +3205,7 @@
       </p:sp>
       <p:sp>
         <p:nvSpPr>
-          <p:cNvPr id="5" name="TextBox 4"/>
+          <p:cNvPr id="4" name="TextBox 3"/>
           <p:cNvSpPr txBox="1"/>
           <p:nvPr/>
         </p:nvSpPr>
@@ -3346,7 +3323,7 @@
       </p:sp>
       <p:sp>
         <p:nvSpPr>
-          <p:cNvPr id="6" name="Rectangle 5"/>
+          <p:cNvPr id="5" name="Rectangle 4"/>
           <p:cNvSpPr/>
           <p:nvPr/>
         </p:nvSpPr>
@@ -3389,7 +3366,7 @@
       </p:sp>
       <p:sp>
         <p:nvSpPr>
-          <p:cNvPr id="7" name="TextBox 6"/>
+          <p:cNvPr id="6" name="TextBox 5"/>
           <p:cNvSpPr txBox="1"/>
           <p:nvPr/>
         </p:nvSpPr>
@@ -3507,7 +3484,7 @@
       </p:sp>
       <p:sp>
         <p:nvSpPr>
-          <p:cNvPr id="8" name="Rectangle 7"/>
+          <p:cNvPr id="7" name="Rectangle 6"/>
           <p:cNvSpPr/>
           <p:nvPr/>
         </p:nvSpPr>
@@ -3550,7 +3527,7 @@
       </p:sp>
       <p:sp>
         <p:nvSpPr>
-          <p:cNvPr id="9" name="Rectangle 8"/>
+          <p:cNvPr id="8" name="Rectangle 7"/>
           <p:cNvSpPr/>
           <p:nvPr/>
         </p:nvSpPr>
@@ -3591,7 +3568,7 @@
       </p:sp>
       <p:sp>
         <p:nvSpPr>
-          <p:cNvPr id="10" name="Rectangle 9"/>
+          <p:cNvPr id="9" name="Rectangle 8"/>
           <p:cNvSpPr/>
           <p:nvPr/>
         </p:nvSpPr>
@@ -3632,7 +3609,7 @@
       </p:sp>
       <p:sp>
         <p:nvSpPr>
-          <p:cNvPr id="11" name="TextBox 10"/>
+          <p:cNvPr id="10" name="TextBox 9"/>
           <p:cNvSpPr txBox="1"/>
           <p:nvPr/>
         </p:nvSpPr>
@@ -3674,7 +3651,7 @@
       </p:sp>
       <p:sp>
         <p:nvSpPr>
-          <p:cNvPr id="12" name="TextBox 11"/>
+          <p:cNvPr id="11" name="TextBox 10"/>
           <p:cNvSpPr txBox="1"/>
           <p:nvPr/>
         </p:nvSpPr>
@@ -3754,7 +3731,7 @@
       </p:sp>
       <p:sp>
         <p:nvSpPr>
-          <p:cNvPr id="13" name="Rectangle 12"/>
+          <p:cNvPr id="12" name="Rectangle 11"/>
           <p:cNvSpPr/>
           <p:nvPr/>
         </p:nvSpPr>
@@ -3797,7 +3774,7 @@
       </p:sp>
       <p:sp>
         <p:nvSpPr>
-          <p:cNvPr id="14" name="Rectangle 13"/>
+          <p:cNvPr id="13" name="Rectangle 12"/>
           <p:cNvSpPr/>
           <p:nvPr/>
         </p:nvSpPr>
@@ -3838,7 +3815,7 @@
       </p:sp>
       <p:sp>
         <p:nvSpPr>
-          <p:cNvPr id="15" name="Rectangle 14"/>
+          <p:cNvPr id="14" name="Rectangle 13"/>
           <p:cNvSpPr/>
           <p:nvPr/>
         </p:nvSpPr>
@@ -3879,7 +3856,7 @@
       </p:sp>
       <p:sp>
         <p:nvSpPr>
-          <p:cNvPr id="16" name="TextBox 15"/>
+          <p:cNvPr id="15" name="TextBox 14"/>
           <p:cNvSpPr txBox="1"/>
           <p:nvPr/>
         </p:nvSpPr>
@@ -3921,7 +3898,7 @@
       </p:sp>
       <p:sp>
         <p:nvSpPr>
-          <p:cNvPr id="17" name="TextBox 16"/>
+          <p:cNvPr id="16" name="TextBox 15"/>
           <p:cNvSpPr txBox="1"/>
           <p:nvPr/>
         </p:nvSpPr>
@@ -4001,7 +3978,7 @@
       </p:sp>
       <p:sp>
         <p:nvSpPr>
-          <p:cNvPr id="18" name="Rectangle 17"/>
+          <p:cNvPr id="17" name="Rectangle 16"/>
           <p:cNvSpPr/>
           <p:nvPr/>
         </p:nvSpPr>
@@ -4044,7 +4021,7 @@
       </p:sp>
       <p:sp>
         <p:nvSpPr>
-          <p:cNvPr id="19" name="Rectangle 18"/>
+          <p:cNvPr id="18" name="Rectangle 17"/>
           <p:cNvSpPr/>
           <p:nvPr/>
         </p:nvSpPr>
@@ -4085,7 +4062,7 @@
       </p:sp>
       <p:sp>
         <p:nvSpPr>
-          <p:cNvPr id="20" name="Rectangle 19"/>
+          <p:cNvPr id="19" name="Rectangle 18"/>
           <p:cNvSpPr/>
           <p:nvPr/>
         </p:nvSpPr>
@@ -4126,7 +4103,7 @@
       </p:sp>
       <p:sp>
         <p:nvSpPr>
-          <p:cNvPr id="21" name="TextBox 20"/>
+          <p:cNvPr id="20" name="TextBox 19"/>
           <p:cNvSpPr txBox="1"/>
           <p:nvPr/>
         </p:nvSpPr>
@@ -4168,7 +4145,7 @@
       </p:sp>
       <p:sp>
         <p:nvSpPr>
-          <p:cNvPr id="22" name="TextBox 21"/>
+          <p:cNvPr id="21" name="TextBox 20"/>
           <p:cNvSpPr txBox="1"/>
           <p:nvPr/>
         </p:nvSpPr>
@@ -4248,7 +4225,7 @@
       </p:sp>
       <p:sp>
         <p:nvSpPr>
-          <p:cNvPr id="23" name="Rectangle 22"/>
+          <p:cNvPr id="22" name="Rectangle 21"/>
           <p:cNvSpPr/>
           <p:nvPr/>
         </p:nvSpPr>
@@ -4291,7 +4268,7 @@
       </p:sp>
       <p:sp>
         <p:nvSpPr>
-          <p:cNvPr id="24" name="Rectangle 23"/>
+          <p:cNvPr id="23" name="Rectangle 22"/>
           <p:cNvSpPr/>
           <p:nvPr/>
         </p:nvSpPr>
@@ -4332,7 +4309,7 @@
       </p:sp>
       <p:sp>
         <p:nvSpPr>
-          <p:cNvPr id="25" name="Rectangle 24"/>
+          <p:cNvPr id="24" name="Rectangle 23"/>
           <p:cNvSpPr/>
           <p:nvPr/>
         </p:nvSpPr>
@@ -4373,7 +4350,7 @@
       </p:sp>
       <p:sp>
         <p:nvSpPr>
-          <p:cNvPr id="26" name="TextBox 25"/>
+          <p:cNvPr id="25" name="TextBox 24"/>
           <p:cNvSpPr txBox="1"/>
           <p:nvPr/>
         </p:nvSpPr>
@@ -4415,7 +4392,7 @@
       </p:sp>
       <p:sp>
         <p:nvSpPr>
-          <p:cNvPr id="27" name="TextBox 26"/>
+          <p:cNvPr id="26" name="TextBox 25"/>
           <p:cNvSpPr txBox="1"/>
           <p:nvPr/>
         </p:nvSpPr>
@@ -4495,7 +4472,7 @@
       </p:sp>
       <p:sp>
         <p:nvSpPr>
-          <p:cNvPr id="28" name="Rectangle 27"/>
+          <p:cNvPr id="27" name="Rectangle 26"/>
           <p:cNvSpPr/>
           <p:nvPr/>
         </p:nvSpPr>
@@ -4538,7 +4515,7 @@
       </p:sp>
       <p:sp>
         <p:nvSpPr>
-          <p:cNvPr id="29" name="Rectangle 28"/>
+          <p:cNvPr id="28" name="Rectangle 27"/>
           <p:cNvSpPr/>
           <p:nvPr/>
         </p:nvSpPr>
@@ -4579,7 +4556,7 @@
       </p:sp>
       <p:sp>
         <p:nvSpPr>
-          <p:cNvPr id="30" name="Rectangle 29"/>
+          <p:cNvPr id="29" name="Rectangle 28"/>
           <p:cNvSpPr/>
           <p:nvPr/>
         </p:nvSpPr>
@@ -4620,7 +4597,7 @@
       </p:sp>
       <p:sp>
         <p:nvSpPr>
-          <p:cNvPr id="31" name="TextBox 30"/>
+          <p:cNvPr id="30" name="TextBox 29"/>
           <p:cNvSpPr txBox="1"/>
           <p:nvPr/>
         </p:nvSpPr>
@@ -4662,7 +4639,7 @@
       </p:sp>
       <p:sp>
         <p:nvSpPr>
-          <p:cNvPr id="32" name="TextBox 31"/>
+          <p:cNvPr id="31" name="TextBox 30"/>
           <p:cNvSpPr txBox="1"/>
           <p:nvPr/>
         </p:nvSpPr>
@@ -4742,7 +4719,7 @@
       </p:sp>
       <p:sp>
         <p:nvSpPr>
-          <p:cNvPr id="33" name="Rectangle 32"/>
+          <p:cNvPr id="32" name="Rectangle 31"/>
           <p:cNvSpPr/>
           <p:nvPr/>
         </p:nvSpPr>
@@ -4785,7 +4762,7 @@
       </p:sp>
       <p:sp>
         <p:nvSpPr>
-          <p:cNvPr id="34" name="Rectangle 33"/>
+          <p:cNvPr id="33" name="Rectangle 32"/>
           <p:cNvSpPr/>
           <p:nvPr/>
         </p:nvSpPr>
@@ -4826,7 +4803,7 @@
       </p:sp>
       <p:sp>
         <p:nvSpPr>
-          <p:cNvPr id="35" name="Rectangle 34"/>
+          <p:cNvPr id="34" name="Rectangle 33"/>
           <p:cNvSpPr/>
           <p:nvPr/>
         </p:nvSpPr>
@@ -4867,7 +4844,7 @@
       </p:sp>
       <p:sp>
         <p:nvSpPr>
-          <p:cNvPr id="36" name="TextBox 35"/>
+          <p:cNvPr id="35" name="TextBox 34"/>
           <p:cNvSpPr txBox="1"/>
           <p:nvPr/>
         </p:nvSpPr>
@@ -4909,7 +4886,7 @@
       </p:sp>
       <p:sp>
         <p:nvSpPr>
-          <p:cNvPr id="37" name="TextBox 36"/>
+          <p:cNvPr id="36" name="TextBox 35"/>
           <p:cNvSpPr txBox="1"/>
           <p:nvPr/>
         </p:nvSpPr>
@@ -4989,7 +4966,7 @@
       </p:sp>
       <p:sp>
         <p:nvSpPr>
-          <p:cNvPr id="38" name="Rectangle 37"/>
+          <p:cNvPr id="37" name="Rectangle 36"/>
           <p:cNvSpPr/>
           <p:nvPr/>
         </p:nvSpPr>
@@ -5032,7 +5009,7 @@
       </p:sp>
       <p:sp>
         <p:nvSpPr>
-          <p:cNvPr id="39" name="Rectangle 38"/>
+          <p:cNvPr id="38" name="Rectangle 37"/>
           <p:cNvSpPr/>
           <p:nvPr/>
         </p:nvSpPr>
@@ -5073,7 +5050,7 @@
       </p:sp>
       <p:sp>
         <p:nvSpPr>
-          <p:cNvPr id="40" name="Rectangle 39"/>
+          <p:cNvPr id="39" name="Rectangle 38"/>
           <p:cNvSpPr/>
           <p:nvPr/>
         </p:nvSpPr>
@@ -5114,7 +5091,7 @@
       </p:sp>
       <p:sp>
         <p:nvSpPr>
-          <p:cNvPr id="41" name="TextBox 40"/>
+          <p:cNvPr id="40" name="TextBox 39"/>
           <p:cNvSpPr txBox="1"/>
           <p:nvPr/>
         </p:nvSpPr>
@@ -5156,7 +5133,7 @@
       </p:sp>
       <p:sp>
         <p:nvSpPr>
-          <p:cNvPr id="42" name="TextBox 41"/>
+          <p:cNvPr id="41" name="TextBox 40"/>
           <p:cNvSpPr txBox="1"/>
           <p:nvPr/>
         </p:nvSpPr>
@@ -5236,7 +5213,7 @@
       </p:sp>
       <p:sp>
         <p:nvSpPr>
-          <p:cNvPr id="43" name="Rectangle 42"/>
+          <p:cNvPr id="42" name="Rectangle 41"/>
           <p:cNvSpPr/>
           <p:nvPr/>
         </p:nvSpPr>
@@ -5279,7 +5256,7 @@
       </p:sp>
       <p:sp>
         <p:nvSpPr>
-          <p:cNvPr id="44" name="Rectangle 43"/>
+          <p:cNvPr id="43" name="Rectangle 42"/>
           <p:cNvSpPr/>
           <p:nvPr/>
         </p:nvSpPr>
@@ -5320,7 +5297,7 @@
       </p:sp>
       <p:sp>
         <p:nvSpPr>
-          <p:cNvPr id="45" name="Rectangle 44"/>
+          <p:cNvPr id="44" name="Rectangle 43"/>
           <p:cNvSpPr/>
           <p:nvPr/>
         </p:nvSpPr>
@@ -5361,7 +5338,7 @@
       </p:sp>
       <p:sp>
         <p:nvSpPr>
-          <p:cNvPr id="46" name="TextBox 45"/>
+          <p:cNvPr id="45" name="TextBox 44"/>
           <p:cNvSpPr txBox="1"/>
           <p:nvPr/>
         </p:nvSpPr>
@@ -5403,7 +5380,7 @@
       </p:sp>
       <p:sp>
         <p:nvSpPr>
-          <p:cNvPr id="47" name="TextBox 46"/>
+          <p:cNvPr id="46" name="TextBox 45"/>
           <p:cNvSpPr txBox="1"/>
           <p:nvPr/>
         </p:nvSpPr>
@@ -5483,7 +5460,7 @@
       </p:sp>
       <p:sp>
         <p:nvSpPr>
-          <p:cNvPr id="48" name="Rectangle 47"/>
+          <p:cNvPr id="47" name="Rectangle 46"/>
           <p:cNvSpPr/>
           <p:nvPr/>
         </p:nvSpPr>
@@ -5524,7 +5501,7 @@
       </p:sp>
       <p:sp>
         <p:nvSpPr>
-          <p:cNvPr id="49" name="TextBox 48"/>
+          <p:cNvPr id="48" name="TextBox 47"/>
           <p:cNvSpPr txBox="1"/>
           <p:nvPr/>
         </p:nvSpPr>

</xml_diff>